<commit_message>
Deck: embed the demo video on slide 5
</commit_message>
<xml_diff>
--- a/demo/slides/TrustLens-deck.pptx
+++ b/demo/slides/TrustLens-deck.pptx
@@ -5221,16 +5221,52 @@
           </a:p>
         </p:txBody>
       </p:sp>
+      <p:sp>
+        <p:nvSpPr>
+          <p:cNvPr id="3" name="card"/>
+          <p:cNvSpPr/>
+          <p:nvPr/>
+        </p:nvSpPr>
+        <p:spPr>
+          <a:xfrm>
+            <a:off x="402336" y="1225296"/>
+            <a:ext cx="4681728" cy="2681478"/>
+          </a:xfrm>
+          <a:prstGeom prst="roundRect">
+            <a:avLst>
+              <a:gd name="adj" fmla="val 2728"/>
+            </a:avLst>
+          </a:prstGeom>
+          <a:solidFill>
+            <a:srgbClr val="FFFFFF"/>
+          </a:solidFill>
+          <a:ln w="9525">
+            <a:solidFill>
+              <a:srgbClr val="EADCCB"/>
+            </a:solidFill>
+            <a:prstDash val="solid"/>
+          </a:ln>
+        </p:spPr>
+      </p:sp>
       <p:pic>
         <p:nvPicPr>
-          <p:cNvPr id="3" name="screenshot" descr="TrustLens result for ci-sleeper: dangerous, with a hidden trigger banner">    </p:cNvPr>
+          <p:cNvPr id="3" name="demo video">
+            <a:hlinkClick r:id="" action="ppaction://media"/>
+          </p:cNvPr>
           <p:cNvPicPr>
             <a:picLocks noChangeAspect="1"/>
           </p:cNvPicPr>
-          <p:nvPr/>
+          <p:nvPr>
+            <a:videoFile r:link="rId1"/>
+            <p:extLst>
+              <p:ext uri="{DAA4B4D4-6D71-4841-9C94-3DE7FCFB9230}">
+                <p14:media xmlns:p14="http://schemas.microsoft.com/office/powerpoint/2010/main" r:embed="rId2"/>
+              </p:ext>
+            </p:extLst>
+          </p:nvPr>
         </p:nvPicPr>
         <p:blipFill>
-          <a:blip r:embed="rId1"/>
+          <a:blip r:embed="rId3"/>
           <a:stretch>
             <a:fillRect/>
           </a:stretch>
@@ -5238,7 +5274,7 @@
         <p:spPr>
           <a:xfrm>
             <a:off x="457200" y="1280160"/>
-            <a:ext cx="4572000" cy="2743200"/>
+            <a:ext cx="4572000" cy="2571750"/>
           </a:xfrm>
           <a:prstGeom prst="rect">
             <a:avLst/>
@@ -5247,7 +5283,7 @@
       </p:pic>
       <p:sp>
         <p:nvSpPr>
-          <p:cNvPr id="4" name="Text 1"/>
+          <p:cNvPr id="5" name="Text 2"/>
           <p:cNvSpPr txBox="1"/>
           <p:nvPr/>
         </p:nvSpPr>
@@ -5278,7 +5314,7 @@
                 <a:ea typeface="Arial" pitchFamily="34" charset="-122"/>
                 <a:cs typeface="Arial" pitchFamily="34" charset="-120"/>
               </a:rPr>
-              <a:t>Recorded run: demo/TrustLens-demo.mp4 (1:29) · live at localhost:5173</a:t>
+              <a:t>Click to play the 90-second recorded run · live app at localhost:5173</a:t>
             </a:r>
             <a:endParaRPr lang="en-US" sz="1000" dirty="0"/>
           </a:p>
@@ -5286,7 +5322,7 @@
       </p:sp>
       <p:sp>
         <p:nvSpPr>
-          <p:cNvPr id="5" name="Text 2"/>
+          <p:cNvPr id="6" name="Text 3"/>
           <p:cNvSpPr txBox="1"/>
           <p:nvPr/>
         </p:nvSpPr>
@@ -5339,7 +5375,7 @@
       </p:sp>
       <p:sp>
         <p:nvSpPr>
-          <p:cNvPr id="6" name="Text 3"/>
+          <p:cNvPr id="7" name="Text 4"/>
           <p:cNvSpPr txBox="1"/>
           <p:nvPr/>
         </p:nvSpPr>
@@ -5378,7 +5414,7 @@
       </p:sp>
       <p:sp>
         <p:nvSpPr>
-          <p:cNvPr id="7" name="Text 4"/>
+          <p:cNvPr id="8" name="Text 5"/>
           <p:cNvSpPr txBox="1"/>
           <p:nvPr/>
         </p:nvSpPr>
@@ -5431,7 +5467,7 @@
       </p:sp>
       <p:sp>
         <p:nvSpPr>
-          <p:cNvPr id="8" name="Text 5"/>
+          <p:cNvPr id="9" name="Text 6"/>
           <p:cNvSpPr txBox="1"/>
           <p:nvPr/>
         </p:nvSpPr>
@@ -5470,7 +5506,7 @@
       </p:sp>
       <p:sp>
         <p:nvSpPr>
-          <p:cNvPr id="9" name="Text 6"/>
+          <p:cNvPr id="10" name="Text 7"/>
           <p:cNvSpPr txBox="1"/>
           <p:nvPr/>
         </p:nvSpPr>
@@ -5523,7 +5559,7 @@
       </p:sp>
       <p:sp>
         <p:nvSpPr>
-          <p:cNvPr id="10" name="Text 7"/>
+          <p:cNvPr id="11" name="Text 8"/>
           <p:cNvSpPr txBox="1"/>
           <p:nvPr/>
         </p:nvSpPr>
@@ -5562,7 +5598,7 @@
       </p:sp>
       <p:sp>
         <p:nvSpPr>
-          <p:cNvPr id="11" name="Text 8"/>
+          <p:cNvPr id="12" name="Text 9"/>
           <p:cNvSpPr txBox="1"/>
           <p:nvPr/>
         </p:nvSpPr>
@@ -5615,7 +5651,7 @@
       </p:sp>
       <p:sp>
         <p:nvSpPr>
-          <p:cNvPr id="12" name="Text 9"/>
+          <p:cNvPr id="13" name="Text 10"/>
           <p:cNvSpPr txBox="1"/>
           <p:nvPr/>
         </p:nvSpPr>
@@ -5654,7 +5690,7 @@
       </p:sp>
       <p:sp>
         <p:nvSpPr>
-          <p:cNvPr id="13" name="Text 10"/>
+          <p:cNvPr id="14" name="Text 11"/>
           <p:cNvSpPr txBox="1"/>
           <p:nvPr/>
         </p:nvSpPr>
@@ -5707,7 +5743,7 @@
       </p:sp>
       <p:sp>
         <p:nvSpPr>
-          <p:cNvPr id="14" name="Text 11"/>
+          <p:cNvPr id="15" name="Text 12"/>
           <p:cNvSpPr txBox="1"/>
           <p:nvPr/>
         </p:nvSpPr>

</xml_diff>